<commit_message>
updated notebook for final review
</commit_message>
<xml_diff>
--- a/doc/Case_study_presentation.pptx
+++ b/doc/Case_study_presentation.pptx
@@ -123,6 +123,11 @@
       </a:defRPr>
     </a:lvl9pPr>
   </p:defaultTextStyle>
+  <p:extLst>
+    <p:ext uri="{EFAFB233-063F-42B5-8137-9DF3F51BA10A}">
+      <p15:sldGuideLst xmlns:p15="http://schemas.microsoft.com/office/powerpoint/2012/main"/>
+    </p:ext>
+  </p:extLst>
 </p:presentation>
 </file>
 
@@ -275,7 +280,7 @@
           <a:p>
             <a:fld id="{E901BB34-2E51-40BC-B085-8411EBBD0BFC}" type="datetimeFigureOut">
               <a:rPr lang="en-GB" smtClean="0"/>
-              <a:t>06/06/2026</a:t>
+              <a:t>17/06/2026</a:t>
             </a:fld>
             <a:endParaRPr lang="en-GB"/>
           </a:p>
@@ -475,7 +480,7 @@
           <a:p>
             <a:fld id="{E901BB34-2E51-40BC-B085-8411EBBD0BFC}" type="datetimeFigureOut">
               <a:rPr lang="en-GB" smtClean="0"/>
-              <a:t>06/06/2026</a:t>
+              <a:t>17/06/2026</a:t>
             </a:fld>
             <a:endParaRPr lang="en-GB"/>
           </a:p>
@@ -685,7 +690,7 @@
           <a:p>
             <a:fld id="{E901BB34-2E51-40BC-B085-8411EBBD0BFC}" type="datetimeFigureOut">
               <a:rPr lang="en-GB" smtClean="0"/>
-              <a:t>06/06/2026</a:t>
+              <a:t>17/06/2026</a:t>
             </a:fld>
             <a:endParaRPr lang="en-GB"/>
           </a:p>
@@ -885,7 +890,7 @@
           <a:p>
             <a:fld id="{E901BB34-2E51-40BC-B085-8411EBBD0BFC}" type="datetimeFigureOut">
               <a:rPr lang="en-GB" smtClean="0"/>
-              <a:t>06/06/2026</a:t>
+              <a:t>17/06/2026</a:t>
             </a:fld>
             <a:endParaRPr lang="en-GB"/>
           </a:p>
@@ -1161,7 +1166,7 @@
           <a:p>
             <a:fld id="{E901BB34-2E51-40BC-B085-8411EBBD0BFC}" type="datetimeFigureOut">
               <a:rPr lang="en-GB" smtClean="0"/>
-              <a:t>06/06/2026</a:t>
+              <a:t>17/06/2026</a:t>
             </a:fld>
             <a:endParaRPr lang="en-GB"/>
           </a:p>
@@ -1429,7 +1434,7 @@
           <a:p>
             <a:fld id="{E901BB34-2E51-40BC-B085-8411EBBD0BFC}" type="datetimeFigureOut">
               <a:rPr lang="en-GB" smtClean="0"/>
-              <a:t>06/06/2026</a:t>
+              <a:t>17/06/2026</a:t>
             </a:fld>
             <a:endParaRPr lang="en-GB"/>
           </a:p>
@@ -1844,7 +1849,7 @@
           <a:p>
             <a:fld id="{E901BB34-2E51-40BC-B085-8411EBBD0BFC}" type="datetimeFigureOut">
               <a:rPr lang="en-GB" smtClean="0"/>
-              <a:t>06/06/2026</a:t>
+              <a:t>17/06/2026</a:t>
             </a:fld>
             <a:endParaRPr lang="en-GB"/>
           </a:p>
@@ -1986,7 +1991,7 @@
           <a:p>
             <a:fld id="{E901BB34-2E51-40BC-B085-8411EBBD0BFC}" type="datetimeFigureOut">
               <a:rPr lang="en-GB" smtClean="0"/>
-              <a:t>06/06/2026</a:t>
+              <a:t>17/06/2026</a:t>
             </a:fld>
             <a:endParaRPr lang="en-GB"/>
           </a:p>
@@ -2099,7 +2104,7 @@
           <a:p>
             <a:fld id="{E901BB34-2E51-40BC-B085-8411EBBD0BFC}" type="datetimeFigureOut">
               <a:rPr lang="en-GB" smtClean="0"/>
-              <a:t>06/06/2026</a:t>
+              <a:t>17/06/2026</a:t>
             </a:fld>
             <a:endParaRPr lang="en-GB"/>
           </a:p>
@@ -2412,7 +2417,7 @@
           <a:p>
             <a:fld id="{E901BB34-2E51-40BC-B085-8411EBBD0BFC}" type="datetimeFigureOut">
               <a:rPr lang="en-GB" smtClean="0"/>
-              <a:t>06/06/2026</a:t>
+              <a:t>17/06/2026</a:t>
             </a:fld>
             <a:endParaRPr lang="en-GB"/>
           </a:p>
@@ -2701,7 +2706,7 @@
           <a:p>
             <a:fld id="{E901BB34-2E51-40BC-B085-8411EBBD0BFC}" type="datetimeFigureOut">
               <a:rPr lang="en-GB" smtClean="0"/>
-              <a:t>06/06/2026</a:t>
+              <a:t>17/06/2026</a:t>
             </a:fld>
             <a:endParaRPr lang="en-GB"/>
           </a:p>
@@ -2944,7 +2949,7 @@
           <a:p>
             <a:fld id="{E901BB34-2E51-40BC-B085-8411EBBD0BFC}" type="datetimeFigureOut">
               <a:rPr lang="en-GB" smtClean="0"/>
-              <a:t>06/06/2026</a:t>
+              <a:t>17/06/2026</a:t>
             </a:fld>
             <a:endParaRPr lang="en-GB"/>
           </a:p>
@@ -22197,7 +22202,13 @@
           <p:cNvGraphicFramePr>
             <a:graphicFrameLocks noGrp="1"/>
           </p:cNvGraphicFramePr>
-          <p:nvPr/>
+          <p:nvPr>
+            <p:extLst>
+              <p:ext uri="{D42A27DB-BD31-4B8C-83A1-F6EECF244321}">
+                <p14:modId xmlns:p14="http://schemas.microsoft.com/office/powerpoint/2010/main" val="2399377916"/>
+              </p:ext>
+            </p:extLst>
+          </p:nvPr>
         </p:nvGraphicFramePr>
         <p:xfrm>
           <a:off x="685800" y="1664208"/>
@@ -22217,21 +22228,21 @@
                     </a:ext>
                   </a:extLst>
                 </a:gridCol>
-                <a:gridCol w="902208">
+                <a:gridCol w="998834">
                   <a:extLst>
                     <a:ext uri="{9D8B030D-6E8A-4147-A177-3AD203B41FA5}">
                       <a16:colId xmlns:a16="http://schemas.microsoft.com/office/drawing/2014/main" val="20001"/>
                     </a:ext>
                   </a:extLst>
                 </a:gridCol>
-                <a:gridCol w="902208">
+                <a:gridCol w="968829">
                   <a:extLst>
                     <a:ext uri="{9D8B030D-6E8A-4147-A177-3AD203B41FA5}">
                       <a16:colId xmlns:a16="http://schemas.microsoft.com/office/drawing/2014/main" val="20002"/>
                     </a:ext>
                   </a:extLst>
                 </a:gridCol>
-                <a:gridCol w="902208">
+                <a:gridCol w="738961">
                   <a:extLst>
                     <a:ext uri="{9D8B030D-6E8A-4147-A177-3AD203B41FA5}">
                       <a16:colId xmlns:a16="http://schemas.microsoft.com/office/drawing/2014/main" val="20003"/>
@@ -22956,7 +22967,7 @@
                     <a:p>
                       <a:pPr algn="ctr"/>
                       <a:r>
-                        <a:rPr sz="1400" b="0" i="0">
+                        <a:rPr sz="1400" b="0" i="0" dirty="0">
                           <a:solidFill>
                             <a:srgbClr val="1D2B28"/>
                           </a:solidFill>

</xml_diff>